<commit_message>
feedback given to player when clicking on the save button in the level editor and bpm cannot be larger than 500
</commit_message>
<xml_diff>
--- a/Initial Poster.pptx
+++ b/Initial Poster.pptx
@@ -104,6 +104,11 @@
       </a:defRPr>
     </a:lvl9pPr>
   </p:defaultTextStyle>
+  <p:extLst>
+    <p:ext uri="{EFAFB233-063F-42B5-8137-9DF3F51BA10A}">
+      <p15:sldGuideLst xmlns:p15="http://schemas.microsoft.com/office/powerpoint/2012/main"/>
+    </p:ext>
+  </p:extLst>
 </p:presentation>
 </file>
 
@@ -256,7 +261,7 @@
           <a:p>
             <a:fld id="{CD94CA2F-90FC-4EEA-8D10-112E176CB7BB}" type="datetimeFigureOut">
               <a:rPr lang="en-GB" smtClean="0"/>
-              <a:t>15/03/2026</a:t>
+              <a:t>16/03/2026</a:t>
             </a:fld>
             <a:endParaRPr lang="en-GB"/>
           </a:p>
@@ -456,7 +461,7 @@
           <a:p>
             <a:fld id="{CD94CA2F-90FC-4EEA-8D10-112E176CB7BB}" type="datetimeFigureOut">
               <a:rPr lang="en-GB" smtClean="0"/>
-              <a:t>15/03/2026</a:t>
+              <a:t>16/03/2026</a:t>
             </a:fld>
             <a:endParaRPr lang="en-GB"/>
           </a:p>
@@ -666,7 +671,7 @@
           <a:p>
             <a:fld id="{CD94CA2F-90FC-4EEA-8D10-112E176CB7BB}" type="datetimeFigureOut">
               <a:rPr lang="en-GB" smtClean="0"/>
-              <a:t>15/03/2026</a:t>
+              <a:t>16/03/2026</a:t>
             </a:fld>
             <a:endParaRPr lang="en-GB"/>
           </a:p>
@@ -866,7 +871,7 @@
           <a:p>
             <a:fld id="{CD94CA2F-90FC-4EEA-8D10-112E176CB7BB}" type="datetimeFigureOut">
               <a:rPr lang="en-GB" smtClean="0"/>
-              <a:t>15/03/2026</a:t>
+              <a:t>16/03/2026</a:t>
             </a:fld>
             <a:endParaRPr lang="en-GB"/>
           </a:p>
@@ -1142,7 +1147,7 @@
           <a:p>
             <a:fld id="{CD94CA2F-90FC-4EEA-8D10-112E176CB7BB}" type="datetimeFigureOut">
               <a:rPr lang="en-GB" smtClean="0"/>
-              <a:t>15/03/2026</a:t>
+              <a:t>16/03/2026</a:t>
             </a:fld>
             <a:endParaRPr lang="en-GB"/>
           </a:p>
@@ -1410,7 +1415,7 @@
           <a:p>
             <a:fld id="{CD94CA2F-90FC-4EEA-8D10-112E176CB7BB}" type="datetimeFigureOut">
               <a:rPr lang="en-GB" smtClean="0"/>
-              <a:t>15/03/2026</a:t>
+              <a:t>16/03/2026</a:t>
             </a:fld>
             <a:endParaRPr lang="en-GB"/>
           </a:p>
@@ -1825,7 +1830,7 @@
           <a:p>
             <a:fld id="{CD94CA2F-90FC-4EEA-8D10-112E176CB7BB}" type="datetimeFigureOut">
               <a:rPr lang="en-GB" smtClean="0"/>
-              <a:t>15/03/2026</a:t>
+              <a:t>16/03/2026</a:t>
             </a:fld>
             <a:endParaRPr lang="en-GB"/>
           </a:p>
@@ -1967,7 +1972,7 @@
           <a:p>
             <a:fld id="{CD94CA2F-90FC-4EEA-8D10-112E176CB7BB}" type="datetimeFigureOut">
               <a:rPr lang="en-GB" smtClean="0"/>
-              <a:t>15/03/2026</a:t>
+              <a:t>16/03/2026</a:t>
             </a:fld>
             <a:endParaRPr lang="en-GB"/>
           </a:p>
@@ -2080,7 +2085,7 @@
           <a:p>
             <a:fld id="{CD94CA2F-90FC-4EEA-8D10-112E176CB7BB}" type="datetimeFigureOut">
               <a:rPr lang="en-GB" smtClean="0"/>
-              <a:t>15/03/2026</a:t>
+              <a:t>16/03/2026</a:t>
             </a:fld>
             <a:endParaRPr lang="en-GB"/>
           </a:p>
@@ -2393,7 +2398,7 @@
           <a:p>
             <a:fld id="{CD94CA2F-90FC-4EEA-8D10-112E176CB7BB}" type="datetimeFigureOut">
               <a:rPr lang="en-GB" smtClean="0"/>
-              <a:t>15/03/2026</a:t>
+              <a:t>16/03/2026</a:t>
             </a:fld>
             <a:endParaRPr lang="en-GB"/>
           </a:p>
@@ -2682,7 +2687,7 @@
           <a:p>
             <a:fld id="{CD94CA2F-90FC-4EEA-8D10-112E176CB7BB}" type="datetimeFigureOut">
               <a:rPr lang="en-GB" smtClean="0"/>
-              <a:t>15/03/2026</a:t>
+              <a:t>16/03/2026</a:t>
             </a:fld>
             <a:endParaRPr lang="en-GB"/>
           </a:p>
@@ -2925,7 +2930,7 @@
           <a:p>
             <a:fld id="{CD94CA2F-90FC-4EEA-8D10-112E176CB7BB}" type="datetimeFigureOut">
               <a:rPr lang="en-GB" smtClean="0"/>
-              <a:t>15/03/2026</a:t>
+              <a:t>16/03/2026</a:t>
             </a:fld>
             <a:endParaRPr lang="en-GB"/>
           </a:p>
@@ -3375,7 +3380,7 @@
         </p:blipFill>
         <p:spPr>
           <a:xfrm>
-            <a:off x="6094552" y="814495"/>
+            <a:off x="6094552" y="1287312"/>
             <a:ext cx="6143628" cy="3445774"/>
           </a:xfrm>
           <a:prstGeom prst="rect">
@@ -3411,7 +3416,7 @@
         </p:blipFill>
         <p:spPr>
           <a:xfrm>
-            <a:off x="-20250" y="814495"/>
+            <a:off x="-20250" y="1287312"/>
             <a:ext cx="6116250" cy="3445774"/>
           </a:xfrm>
           <a:prstGeom prst="rect">
@@ -3603,50 +3608,123 @@
       </p:pic>
       <p:sp>
         <p:nvSpPr>
-          <p:cNvPr id="10" name="Rectangle 9">
-            <a:extLst>
-              <a:ext uri="{FF2B5EF4-FFF2-40B4-BE49-F238E27FC236}">
-                <a16:creationId xmlns:a16="http://schemas.microsoft.com/office/drawing/2014/main" id="{F84017A2-CC29-2F4B-33EE-E6761396561C}"/>
-              </a:ext>
-            </a:extLst>
-          </p:cNvPr>
-          <p:cNvSpPr/>
+          <p:cNvPr id="2" name="TextBox 1">
+            <a:extLst>
+              <a:ext uri="{FF2B5EF4-FFF2-40B4-BE49-F238E27FC236}">
+                <a16:creationId xmlns:a16="http://schemas.microsoft.com/office/drawing/2014/main" id="{1B21CC54-5449-A818-F2A5-B564045DD7DE}"/>
+              </a:ext>
+            </a:extLst>
+          </p:cNvPr>
+          <p:cNvSpPr txBox="1"/>
           <p:nvPr/>
         </p:nvSpPr>
         <p:spPr>
           <a:xfrm>
-            <a:off x="0" y="0"/>
-            <a:ext cx="12192000" cy="804054"/>
+            <a:off x="147484" y="4733086"/>
+            <a:ext cx="5761703" cy="646331"/>
           </a:xfrm>
           <a:prstGeom prst="rect">
             <a:avLst/>
           </a:prstGeom>
-          <a:solidFill>
-            <a:schemeClr val="tx2"/>
-          </a:solidFill>
+          <a:noFill/>
         </p:spPr>
-        <p:style>
-          <a:lnRef idx="2">
-            <a:schemeClr val="accent1">
-              <a:shade val="15000"/>
-            </a:schemeClr>
-          </a:lnRef>
-          <a:fillRef idx="1">
-            <a:schemeClr val="accent1"/>
-          </a:fillRef>
-          <a:effectRef idx="0">
-            <a:schemeClr val="accent1"/>
-          </a:effectRef>
-          <a:fontRef idx="minor">
-            <a:schemeClr val="lt1"/>
-          </a:fontRef>
-        </p:style>
-        <p:txBody>
-          <a:bodyPr rtlCol="0" anchor="ctr"/>
-          <a:lstStyle/>
-          <a:p>
-            <a:pPr algn="ctr"/>
-            <a:endParaRPr lang="en-GB"/>
+        <p:txBody>
+          <a:bodyPr wrap="square" rtlCol="0">
+            <a:spAutoFit/>
+          </a:bodyPr>
+          <a:lstStyle/>
+          <a:p>
+            <a:r>
+              <a:rPr lang="en-GB" dirty="0">
+                <a:solidFill>
+                  <a:schemeClr val="bg1"/>
+                </a:solidFill>
+              </a:rPr>
+              <a:t>Precise controller gameplay where you have to time your hits to the music</a:t>
+            </a:r>
+          </a:p>
+        </p:txBody>
+      </p:sp>
+      <p:sp>
+        <p:nvSpPr>
+          <p:cNvPr id="3" name="TextBox 2">
+            <a:extLst>
+              <a:ext uri="{FF2B5EF4-FFF2-40B4-BE49-F238E27FC236}">
+                <a16:creationId xmlns:a16="http://schemas.microsoft.com/office/drawing/2014/main" id="{E4A3B138-3362-14C5-6F38-4DB51A68B260}"/>
+              </a:ext>
+            </a:extLst>
+          </p:cNvPr>
+          <p:cNvSpPr txBox="1"/>
+          <p:nvPr/>
+        </p:nvSpPr>
+        <p:spPr>
+          <a:xfrm>
+            <a:off x="6194323" y="4733086"/>
+            <a:ext cx="5928851" cy="646331"/>
+          </a:xfrm>
+          <a:prstGeom prst="rect">
+            <a:avLst/>
+          </a:prstGeom>
+          <a:noFill/>
+        </p:spPr>
+        <p:txBody>
+          <a:bodyPr wrap="square" rtlCol="0">
+            <a:spAutoFit/>
+          </a:bodyPr>
+          <a:lstStyle/>
+          <a:p>
+            <a:r>
+              <a:rPr lang="en-GB" dirty="0">
+                <a:solidFill>
+                  <a:schemeClr val="bg1"/>
+                </a:solidFill>
+              </a:rPr>
+              <a:t>Create your own levels using the in-game level editor where you can even add your own music</a:t>
+            </a:r>
+          </a:p>
+        </p:txBody>
+      </p:sp>
+      <p:sp>
+        <p:nvSpPr>
+          <p:cNvPr id="4" name="TextBox 3">
+            <a:extLst>
+              <a:ext uri="{FF2B5EF4-FFF2-40B4-BE49-F238E27FC236}">
+                <a16:creationId xmlns:a16="http://schemas.microsoft.com/office/drawing/2014/main" id="{EE1B5A69-FED3-3EEE-E5A7-E983E416CADF}"/>
+              </a:ext>
+            </a:extLst>
+          </p:cNvPr>
+          <p:cNvSpPr txBox="1"/>
+          <p:nvPr/>
+        </p:nvSpPr>
+        <p:spPr>
+          <a:xfrm>
+            <a:off x="4560719" y="258840"/>
+            <a:ext cx="3067665" cy="707886"/>
+          </a:xfrm>
+          <a:prstGeom prst="rect">
+            <a:avLst/>
+          </a:prstGeom>
+          <a:noFill/>
+        </p:spPr>
+        <p:txBody>
+          <a:bodyPr wrap="square" rtlCol="0">
+            <a:spAutoFit/>
+          </a:bodyPr>
+          <a:lstStyle/>
+          <a:p>
+            <a:r>
+              <a:rPr lang="en-GB" sz="4000" dirty="0" err="1">
+                <a:solidFill>
+                  <a:schemeClr val="bg1"/>
+                </a:solidFill>
+              </a:rPr>
+              <a:t>Rhythmix</a:t>
+            </a:r>
+            <a:endParaRPr lang="en-GB" sz="4000" dirty="0">
+              <a:solidFill>
+                <a:schemeClr val="bg1"/>
+              </a:solidFill>
+            </a:endParaRPr>
           </a:p>
         </p:txBody>
       </p:sp>

</xml_diff>